<commit_message>
Presentation: add scaling results slide, fix data numbers, fix slide titles
</commit_message>
<xml_diff>
--- a/VKRDoc/Defense_Presentation.pptx
+++ b/VKRDoc/Defense_Presentation.pptx
@@ -13,6 +13,7 @@
     <p:sldId id="261" r:id="rId12"/>
     <p:sldId id="262" r:id="rId13"/>
     <p:sldId id="263" r:id="rId14"/>
+    <p:sldId id="300" r:id="rId22"/>
     <p:sldId id="268" r:id="rId19"/>
     <p:sldId id="269" r:id="rId20"/>
     <p:sldId id="270" r:id="rId21"/>
@@ -5197,7 +5198,7 @@
               </a:defRPr>
             </a:pPr>
             <a:r>
-              <a:t>Confusion Matrix и ROC (лучшая модель A2)</a:t>
+              <a:t>Confusion Matrix и ROC (in-domain, DFDC02)</a:t>
             </a:r>
           </a:p>
         </p:txBody>
@@ -5314,6 +5315,766 @@
           </a:prstGeom>
         </p:spPr>
       </p:pic>
+    </p:spTree>
+  </p:cSld>
+  <p:clrMapOvr>
+    <a:masterClrMapping/>
+  </p:clrMapOvr>
+</p:sld>
+</file>
+
+<file path=ppt/slides/slide16.xml><?xml version="1.0" encoding="utf-8"?>
+<p:sld xmlns:a="http://schemas.openxmlformats.org/drawingml/2006/main" xmlns:p="http://schemas.openxmlformats.org/presentationml/2006/main" xmlns:r="http://schemas.openxmlformats.org/officeDocument/2006/relationships">
+  <p:cSld>
+    <p:bg>
+      <p:bgPr>
+        <a:solidFill>
+          <a:srgbClr val="FFFFFF"/>
+        </a:solidFill>
+        <a:effectLst/>
+      </p:bgPr>
+    </p:bg>
+    <p:spTree>
+      <p:nvGrpSpPr>
+        <p:cNvPr id="1" name=""/>
+        <p:cNvGrpSpPr/>
+        <p:nvPr/>
+      </p:nvGrpSpPr>
+      <p:grpSpPr/>
+      <p:sp>
+        <p:nvSpPr>
+          <p:cNvPr id="2" name="Rectangle 1"/>
+          <p:cNvSpPr/>
+          <p:nvPr/>
+        </p:nvSpPr>
+        <p:spPr>
+          <a:xfrm>
+            <a:off x="0" y="0"/>
+            <a:ext cx="12191695" cy="1005840"/>
+          </a:xfrm>
+          <a:prstGeom prst="rect">
+            <a:avLst/>
+          </a:prstGeom>
+          <a:solidFill>
+            <a:srgbClr val="003366"/>
+          </a:solidFill>
+          <a:ln>
+            <a:noFill/>
+          </a:ln>
+        </p:spPr>
+        <p:style>
+          <a:lnRef idx="1">
+            <a:schemeClr val="accent1"/>
+          </a:lnRef>
+          <a:fillRef idx="3">
+            <a:schemeClr val="accent1"/>
+          </a:fillRef>
+          <a:effectRef idx="2">
+            <a:schemeClr val="accent1"/>
+          </a:effectRef>
+          <a:fontRef idx="minor">
+            <a:schemeClr val="lt1"/>
+          </a:fontRef>
+        </p:style>
+        <p:txBody>
+          <a:bodyPr rtlCol="0" anchor="ctr"/>
+          <a:lstStyle/>
+          <a:p>
+            <a:pPr algn="ctr"/>
+          </a:p>
+        </p:txBody>
+      </p:sp>
+      <p:sp>
+        <p:nvSpPr>
+          <p:cNvPr id="3" name="TextBox 2"/>
+          <p:cNvSpPr txBox="1"/>
+          <p:nvPr/>
+        </p:nvSpPr>
+        <p:spPr>
+          <a:xfrm>
+            <a:off x="548640" y="137160"/>
+            <a:ext cx="10972800" cy="822960"/>
+          </a:xfrm>
+          <a:prstGeom prst="rect">
+            <a:avLst/>
+          </a:prstGeom>
+          <a:noFill/>
+        </p:spPr>
+        <p:txBody>
+          <a:bodyPr wrap="square">
+            <a:spAutoFit/>
+          </a:bodyPr>
+          <a:lstStyle/>
+          <a:p>
+            <a:pPr algn="l">
+              <a:defRPr sz="2800" b="1">
+                <a:solidFill>
+                  <a:srgbClr val="FFFFFF"/>
+                </a:solidFill>
+              </a:defRPr>
+            </a:pPr>
+            <a:r>
+              <a:t>Масштабирование: 3 датасета + T=32</a:t>
+            </a:r>
+          </a:p>
+        </p:txBody>
+      </p:sp>
+      <p:sp>
+        <p:nvSpPr>
+          <p:cNvPr id="4" name="Rectangle 3"/>
+          <p:cNvSpPr/>
+          <p:nvPr/>
+        </p:nvSpPr>
+        <p:spPr>
+          <a:xfrm>
+            <a:off x="0" y="6492240"/>
+            <a:ext cx="12191695" cy="365760"/>
+          </a:xfrm>
+          <a:prstGeom prst="rect">
+            <a:avLst/>
+          </a:prstGeom>
+          <a:solidFill>
+            <a:srgbClr val="003366"/>
+          </a:solidFill>
+          <a:ln>
+            <a:noFill/>
+          </a:ln>
+        </p:spPr>
+        <p:style>
+          <a:lnRef idx="1">
+            <a:schemeClr val="accent1"/>
+          </a:lnRef>
+          <a:fillRef idx="3">
+            <a:schemeClr val="accent1"/>
+          </a:fillRef>
+          <a:effectRef idx="2">
+            <a:schemeClr val="accent1"/>
+          </a:effectRef>
+          <a:fontRef idx="minor">
+            <a:schemeClr val="lt1"/>
+          </a:fontRef>
+        </p:style>
+        <p:txBody>
+          <a:bodyPr rtlCol="0" anchor="ctr"/>
+          <a:lstStyle/>
+          <a:p>
+            <a:pPr algn="ctr"/>
+          </a:p>
+        </p:txBody>
+      </p:sp>
+      <p:sp>
+        <p:nvSpPr>
+          <p:cNvPr id="5" name="TextBox 4"/>
+          <p:cNvSpPr txBox="1"/>
+          <p:nvPr/>
+        </p:nvSpPr>
+        <p:spPr>
+          <a:xfrm>
+            <a:off x="11430000" y="6537960"/>
+            <a:ext cx="640080" cy="274320"/>
+          </a:xfrm>
+          <a:prstGeom prst="rect">
+            <a:avLst/>
+          </a:prstGeom>
+          <a:noFill/>
+        </p:spPr>
+        <p:txBody>
+          <a:bodyPr wrap="none">
+            <a:spAutoFit/>
+          </a:bodyPr>
+          <a:lstStyle/>
+          <a:p>
+            <a:pPr algn="r">
+              <a:defRPr sz="1000">
+                <a:solidFill>
+                  <a:srgbClr val="FFFFFF"/>
+                </a:solidFill>
+              </a:defRPr>
+            </a:pPr>
+            <a:r>
+              <a:t>8/15</a:t>
+            </a:r>
+          </a:p>
+        </p:txBody>
+      </p:sp>
+      <p:graphicFrame>
+        <p:nvGraphicFramePr>
+          <p:cNvPr id="6" name="Table 5"/>
+          <p:cNvGraphicFramePr>
+            <a:graphicFrameLocks noGrp="1"/>
+          </p:cNvGraphicFramePr>
+          <p:nvPr/>
+        </p:nvGraphicFramePr>
+        <p:xfrm>
+          <a:off x="914400" y="1645920"/>
+          <a:ext cx="10058400" cy="2560320"/>
+        </p:xfrm>
+        <a:graphic>
+          <a:graphicData uri="http://schemas.openxmlformats.org/drawingml/2006/table">
+            <a:tbl>
+              <a:tblPr firstRow="1" bandRow="1">
+                <a:tableStyleId>{5C22544A-7EE6-4342-B048-85BDC9FD1C3A}</a:tableStyleId>
+              </a:tblPr>
+              <a:tblGrid>
+                <a:gridCol w="4572000"/>
+                <a:gridCol w="1828800"/>
+                <a:gridCol w="1828800"/>
+                <a:gridCol w="1828800"/>
+              </a:tblGrid>
+              <a:tr h="512064">
+                <a:tc>
+                  <a:txBody>
+                    <a:bodyPr/>
+                    <a:lstStyle/>
+                    <a:p>
+                      <a:pPr algn="ctr">
+                        <a:defRPr sz="1600" b="1">
+                          <a:solidFill>
+                            <a:srgbClr val="FFFFFF"/>
+                          </a:solidFill>
+                        </a:defRPr>
+                      </a:pPr>
+                      <a:r>
+                        <a:t>Конфигурация</a:t>
+                      </a:r>
+                    </a:p>
+                  </a:txBody>
+                  <a:tcPr anchor="ctr">
+                    <a:solidFill>
+                      <a:srgbClr val="003366"/>
+                    </a:solidFill>
+                  </a:tcPr>
+                </a:tc>
+                <a:tc>
+                  <a:txBody>
+                    <a:bodyPr/>
+                    <a:lstStyle/>
+                    <a:p>
+                      <a:pPr algn="ctr">
+                        <a:defRPr sz="1600" b="1">
+                          <a:solidFill>
+                            <a:srgbClr val="FFFFFF"/>
+                          </a:solidFill>
+                        </a:defRPr>
+                      </a:pPr>
+                      <a:r>
+                        <a:t>AUC</a:t>
+                      </a:r>
+                    </a:p>
+                  </a:txBody>
+                  <a:tcPr anchor="ctr">
+                    <a:solidFill>
+                      <a:srgbClr val="003366"/>
+                    </a:solidFill>
+                  </a:tcPr>
+                </a:tc>
+                <a:tc>
+                  <a:txBody>
+                    <a:bodyPr/>
+                    <a:lstStyle/>
+                    <a:p>
+                      <a:pPr algn="ctr">
+                        <a:defRPr sz="1600" b="1">
+                          <a:solidFill>
+                            <a:srgbClr val="FFFFFF"/>
+                          </a:solidFill>
+                        </a:defRPr>
+                      </a:pPr>
+                      <a:r>
+                        <a:t>Acc</a:t>
+                      </a:r>
+                    </a:p>
+                  </a:txBody>
+                  <a:tcPr anchor="ctr">
+                    <a:solidFill>
+                      <a:srgbClr val="003366"/>
+                    </a:solidFill>
+                  </a:tcPr>
+                </a:tc>
+                <a:tc>
+                  <a:txBody>
+                    <a:bodyPr/>
+                    <a:lstStyle/>
+                    <a:p>
+                      <a:pPr algn="ctr">
+                        <a:defRPr sz="1600" b="1">
+                          <a:solidFill>
+                            <a:srgbClr val="FFFFFF"/>
+                          </a:solidFill>
+                        </a:defRPr>
+                      </a:pPr>
+                      <a:r>
+                        <a:t>EER</a:t>
+                      </a:r>
+                    </a:p>
+                  </a:txBody>
+                  <a:tcPr anchor="ctr">
+                    <a:solidFill>
+                      <a:srgbClr val="003366"/>
+                    </a:solidFill>
+                  </a:tcPr>
+                </a:tc>
+              </a:tr>
+              <a:tr h="512064">
+                <a:tc>
+                  <a:txBody>
+                    <a:bodyPr/>
+                    <a:lstStyle/>
+                    <a:p>
+                      <a:pPr algn="l">
+                        <a:defRPr sz="1500" b="0">
+                          <a:solidFill>
+                            <a:srgbClr val="000000"/>
+                          </a:solidFill>
+                        </a:defRPr>
+                      </a:pPr>
+                      <a:r>
+                        <a:t>1DS DFDC02, T=16</a:t>
+                      </a:r>
+                    </a:p>
+                  </a:txBody>
+                  <a:tcPr anchor="ctr">
+                    <a:solidFill>
+                      <a:srgbClr val="F5F5F5"/>
+                    </a:solidFill>
+                  </a:tcPr>
+                </a:tc>
+                <a:tc>
+                  <a:txBody>
+                    <a:bodyPr/>
+                    <a:lstStyle/>
+                    <a:p>
+                      <a:pPr algn="ctr">
+                        <a:defRPr sz="1500" b="0">
+                          <a:solidFill>
+                            <a:srgbClr val="000000"/>
+                          </a:solidFill>
+                        </a:defRPr>
+                      </a:pPr>
+                      <a:r>
+                        <a:t>0.9777</a:t>
+                      </a:r>
+                    </a:p>
+                  </a:txBody>
+                  <a:tcPr anchor="ctr">
+                    <a:solidFill>
+                      <a:srgbClr val="F5F5F5"/>
+                    </a:solidFill>
+                  </a:tcPr>
+                </a:tc>
+                <a:tc>
+                  <a:txBody>
+                    <a:bodyPr/>
+                    <a:lstStyle/>
+                    <a:p>
+                      <a:pPr algn="ctr">
+                        <a:defRPr sz="1500" b="0">
+                          <a:solidFill>
+                            <a:srgbClr val="000000"/>
+                          </a:solidFill>
+                        </a:defRPr>
+                      </a:pPr>
+                      <a:r>
+                        <a:t>0.9253</a:t>
+                      </a:r>
+                    </a:p>
+                  </a:txBody>
+                  <a:tcPr anchor="ctr">
+                    <a:solidFill>
+                      <a:srgbClr val="F5F5F5"/>
+                    </a:solidFill>
+                  </a:tcPr>
+                </a:tc>
+                <a:tc>
+                  <a:txBody>
+                    <a:bodyPr/>
+                    <a:lstStyle/>
+                    <a:p>
+                      <a:pPr algn="ctr">
+                        <a:defRPr sz="1500" b="0">
+                          <a:solidFill>
+                            <a:srgbClr val="000000"/>
+                          </a:solidFill>
+                        </a:defRPr>
+                      </a:pPr>
+                      <a:r>
+                        <a:t>0.075</a:t>
+                      </a:r>
+                    </a:p>
+                  </a:txBody>
+                  <a:tcPr anchor="ctr">
+                    <a:solidFill>
+                      <a:srgbClr val="F5F5F5"/>
+                    </a:solidFill>
+                  </a:tcPr>
+                </a:tc>
+              </a:tr>
+              <a:tr h="512064">
+                <a:tc>
+                  <a:txBody>
+                    <a:bodyPr/>
+                    <a:lstStyle/>
+                    <a:p>
+                      <a:pPr algn="l">
+                        <a:defRPr sz="1500" b="0">
+                          <a:solidFill>
+                            <a:srgbClr val="000000"/>
+                          </a:solidFill>
+                        </a:defRPr>
+                      </a:pPr>
+                      <a:r>
+                        <a:t>2DS +DFD01, T=16</a:t>
+                      </a:r>
+                    </a:p>
+                  </a:txBody>
+                  <a:tcPr anchor="ctr">
+                    <a:solidFill>
+                      <a:srgbClr val="FFFFFF"/>
+                    </a:solidFill>
+                  </a:tcPr>
+                </a:tc>
+                <a:tc>
+                  <a:txBody>
+                    <a:bodyPr/>
+                    <a:lstStyle/>
+                    <a:p>
+                      <a:pPr algn="ctr">
+                        <a:defRPr sz="1500" b="0">
+                          <a:solidFill>
+                            <a:srgbClr val="000000"/>
+                          </a:solidFill>
+                        </a:defRPr>
+                      </a:pPr>
+                      <a:r>
+                        <a:t>0.8990</a:t>
+                      </a:r>
+                    </a:p>
+                  </a:txBody>
+                  <a:tcPr anchor="ctr">
+                    <a:solidFill>
+                      <a:srgbClr val="FFFFFF"/>
+                    </a:solidFill>
+                  </a:tcPr>
+                </a:tc>
+                <a:tc>
+                  <a:txBody>
+                    <a:bodyPr/>
+                    <a:lstStyle/>
+                    <a:p>
+                      <a:pPr algn="ctr">
+                        <a:defRPr sz="1500" b="0">
+                          <a:solidFill>
+                            <a:srgbClr val="000000"/>
+                          </a:solidFill>
+                        </a:defRPr>
+                      </a:pPr>
+                      <a:r>
+                        <a:t>0.8770</a:t>
+                      </a:r>
+                    </a:p>
+                  </a:txBody>
+                  <a:tcPr anchor="ctr">
+                    <a:solidFill>
+                      <a:srgbClr val="FFFFFF"/>
+                    </a:solidFill>
+                  </a:tcPr>
+                </a:tc>
+                <a:tc>
+                  <a:txBody>
+                    <a:bodyPr/>
+                    <a:lstStyle/>
+                    <a:p>
+                      <a:pPr algn="ctr">
+                        <a:defRPr sz="1500" b="0">
+                          <a:solidFill>
+                            <a:srgbClr val="000000"/>
+                          </a:solidFill>
+                        </a:defRPr>
+                      </a:pPr>
+                      <a:r>
+                        <a:t>0.194</a:t>
+                      </a:r>
+                    </a:p>
+                  </a:txBody>
+                  <a:tcPr anchor="ctr">
+                    <a:solidFill>
+                      <a:srgbClr val="FFFFFF"/>
+                    </a:solidFill>
+                  </a:tcPr>
+                </a:tc>
+              </a:tr>
+              <a:tr h="512064">
+                <a:tc>
+                  <a:txBody>
+                    <a:bodyPr/>
+                    <a:lstStyle/>
+                    <a:p>
+                      <a:pPr algn="l">
+                        <a:defRPr sz="1500" b="0">
+                          <a:solidFill>
+                            <a:srgbClr val="000000"/>
+                          </a:solidFill>
+                        </a:defRPr>
+                      </a:pPr>
+                      <a:r>
+                        <a:t>3DS +CelebDF, T=16</a:t>
+                      </a:r>
+                    </a:p>
+                  </a:txBody>
+                  <a:tcPr anchor="ctr">
+                    <a:solidFill>
+                      <a:srgbClr val="F5F5F5"/>
+                    </a:solidFill>
+                  </a:tcPr>
+                </a:tc>
+                <a:tc>
+                  <a:txBody>
+                    <a:bodyPr/>
+                    <a:lstStyle/>
+                    <a:p>
+                      <a:pPr algn="ctr">
+                        <a:defRPr sz="1500" b="0">
+                          <a:solidFill>
+                            <a:srgbClr val="000000"/>
+                          </a:solidFill>
+                        </a:defRPr>
+                      </a:pPr>
+                      <a:r>
+                        <a:t>0.9587</a:t>
+                      </a:r>
+                    </a:p>
+                  </a:txBody>
+                  <a:tcPr anchor="ctr">
+                    <a:solidFill>
+                      <a:srgbClr val="F5F5F5"/>
+                    </a:solidFill>
+                  </a:tcPr>
+                </a:tc>
+                <a:tc>
+                  <a:txBody>
+                    <a:bodyPr/>
+                    <a:lstStyle/>
+                    <a:p>
+                      <a:pPr algn="ctr">
+                        <a:defRPr sz="1500" b="0">
+                          <a:solidFill>
+                            <a:srgbClr val="000000"/>
+                          </a:solidFill>
+                        </a:defRPr>
+                      </a:pPr>
+                      <a:r>
+                        <a:t>0.9436</a:t>
+                      </a:r>
+                    </a:p>
+                  </a:txBody>
+                  <a:tcPr anchor="ctr">
+                    <a:solidFill>
+                      <a:srgbClr val="F5F5F5"/>
+                    </a:solidFill>
+                  </a:tcPr>
+                </a:tc>
+                <a:tc>
+                  <a:txBody>
+                    <a:bodyPr/>
+                    <a:lstStyle/>
+                    <a:p>
+                      <a:pPr algn="ctr">
+                        <a:defRPr sz="1500" b="0">
+                          <a:solidFill>
+                            <a:srgbClr val="000000"/>
+                          </a:solidFill>
+                        </a:defRPr>
+                      </a:pPr>
+                      <a:r>
+                        <a:t>0.121</a:t>
+                      </a:r>
+                    </a:p>
+                  </a:txBody>
+                  <a:tcPr anchor="ctr">
+                    <a:solidFill>
+                      <a:srgbClr val="F5F5F5"/>
+                    </a:solidFill>
+                  </a:tcPr>
+                </a:tc>
+              </a:tr>
+              <a:tr h="512064">
+                <a:tc>
+                  <a:txBody>
+                    <a:bodyPr/>
+                    <a:lstStyle/>
+                    <a:p>
+                      <a:pPr algn="l">
+                        <a:defRPr sz="1500" b="1">
+                          <a:solidFill>
+                            <a:srgbClr val="003366"/>
+                          </a:solidFill>
+                        </a:defRPr>
+                      </a:pPr>
+                      <a:r>
+                        <a:t>3DS +CelebDF, T=32</a:t>
+                      </a:r>
+                    </a:p>
+                  </a:txBody>
+                  <a:tcPr anchor="ctr">
+                    <a:solidFill>
+                      <a:srgbClr val="E0EBF5"/>
+                    </a:solidFill>
+                  </a:tcPr>
+                </a:tc>
+                <a:tc>
+                  <a:txBody>
+                    <a:bodyPr/>
+                    <a:lstStyle/>
+                    <a:p>
+                      <a:pPr algn="ctr">
+                        <a:defRPr sz="1500" b="1">
+                          <a:solidFill>
+                            <a:srgbClr val="003366"/>
+                          </a:solidFill>
+                        </a:defRPr>
+                      </a:pPr>
+                      <a:r>
+                        <a:t>0.9943</a:t>
+                      </a:r>
+                    </a:p>
+                  </a:txBody>
+                  <a:tcPr anchor="ctr">
+                    <a:solidFill>
+                      <a:srgbClr val="E0EBF5"/>
+                    </a:solidFill>
+                  </a:tcPr>
+                </a:tc>
+                <a:tc>
+                  <a:txBody>
+                    <a:bodyPr/>
+                    <a:lstStyle/>
+                    <a:p>
+                      <a:pPr algn="ctr">
+                        <a:defRPr sz="1500" b="1">
+                          <a:solidFill>
+                            <a:srgbClr val="003366"/>
+                          </a:solidFill>
+                        </a:defRPr>
+                      </a:pPr>
+                      <a:r>
+                        <a:t>0.9672</a:t>
+                      </a:r>
+                    </a:p>
+                  </a:txBody>
+                  <a:tcPr anchor="ctr">
+                    <a:solidFill>
+                      <a:srgbClr val="E0EBF5"/>
+                    </a:solidFill>
+                  </a:tcPr>
+                </a:tc>
+                <a:tc>
+                  <a:txBody>
+                    <a:bodyPr/>
+                    <a:lstStyle/>
+                    <a:p>
+                      <a:pPr algn="ctr">
+                        <a:defRPr sz="1500" b="1">
+                          <a:solidFill>
+                            <a:srgbClr val="003366"/>
+                          </a:solidFill>
+                        </a:defRPr>
+                      </a:pPr>
+                      <a:r>
+                        <a:t>0.041</a:t>
+                      </a:r>
+                    </a:p>
+                  </a:txBody>
+                  <a:tcPr anchor="ctr">
+                    <a:solidFill>
+                      <a:srgbClr val="E0EBF5"/>
+                    </a:solidFill>
+                  </a:tcPr>
+                </a:tc>
+              </a:tr>
+            </a:tbl>
+          </a:graphicData>
+        </a:graphic>
+      </p:graphicFrame>
+      <p:sp>
+        <p:nvSpPr>
+          <p:cNvPr id="7" name="TextBox 6"/>
+          <p:cNvSpPr txBox="1"/>
+          <p:nvPr/>
+        </p:nvSpPr>
+        <p:spPr>
+          <a:xfrm>
+            <a:off x="914400" y="4572000"/>
+            <a:ext cx="10058400" cy="1371600"/>
+          </a:xfrm>
+          <a:prstGeom prst="rect">
+            <a:avLst/>
+          </a:prstGeom>
+          <a:noFill/>
+        </p:spPr>
+        <p:txBody>
+          <a:bodyPr wrap="square">
+            <a:spAutoFit/>
+          </a:bodyPr>
+          <a:lstStyle/>
+          <a:p>
+            <a:pPr>
+              <a:defRPr sz="1700" b="1">
+                <a:solidFill>
+                  <a:srgbClr val="003366"/>
+                </a:solidFill>
+              </a:defRPr>
+            </a:pPr>
+            <a:r>
+              <a:t>Ключевой вывод:</a:t>
+            </a:r>
+          </a:p>
+          <a:p>
+            <a:pPr>
+              <a:spcBef>
+                <a:spcPts val="600"/>
+              </a:spcBef>
+              <a:defRPr sz="1500" b="0">
+                <a:solidFill>
+                  <a:srgbClr val="000000"/>
+                </a:solidFill>
+              </a:defRPr>
+            </a:pPr>
+            <a:r>
+              <a:t>Мультидатасетное обучение: AUC 0.978 → 0.899 → 0.959 → 0.994</a:t>
+            </a:r>
+          </a:p>
+          <a:p>
+            <a:pPr>
+              <a:spcBef>
+                <a:spcPts val="600"/>
+              </a:spcBef>
+              <a:defRPr sz="1500" b="0">
+                <a:solidFill>
+                  <a:srgbClr val="000000"/>
+                </a:solidFill>
+              </a:defRPr>
+            </a:pPr>
+            <a:r>
+              <a:t>T=32 снижает EER на 66% (0.121 → 0.041)</a:t>
+            </a:r>
+          </a:p>
+          <a:p>
+            <a:pPr>
+              <a:spcBef>
+                <a:spcPts val="600"/>
+              </a:spcBef>
+              <a:defRPr sz="1500" b="1">
+                <a:solidFill>
+                  <a:srgbClr val="CC5500"/>
+                </a:solidFill>
+              </a:defRPr>
+            </a:pPr>
+            <a:r>
+              <a:t>Full dual-path модель лидирует при всех конфигурациях на 3 датасетах</a:t>
+            </a:r>
+          </a:p>
+        </p:txBody>
+      </p:sp>
     </p:spTree>
   </p:cSld>
   <p:clrMapOvr>
@@ -9082,7 +9843,7 @@
               </a:defRPr>
             </a:pPr>
             <a:r>
-              <a:t>DFDC subset: 2303 train / 493 val / 496 test</a:t>
+              <a:t>3 датасета (DFDC02+DFD01+CelebDF): ~10000 видео</a:t>
             </a:r>
           </a:p>
           <a:p>

</xml_diff>

<commit_message>
Presentation: add student/supervisor names, direction, update format
- Added Тараканов А.А. and Смирнов Д.С. to title slide
- Changed to "Выпускная квалификационная работа магистра"
- Added direction 01.04.02
</commit_message>
<xml_diff>
--- a/VKRDoc/Defense_Presentation.pptx
+++ b/VKRDoc/Defense_Presentation.pptx
@@ -3094,7 +3094,7 @@
 </file>
 
 <file path=ppt/slides/slide1.xml><?xml version="1.0" encoding="utf-8"?>
-<p:sld xmlns:a="http://schemas.openxmlformats.org/drawingml/2006/main" xmlns:p="http://schemas.openxmlformats.org/presentationml/2006/main" xmlns:r="http://schemas.openxmlformats.org/officeDocument/2006/relationships">
+<p:sld xmlns:a="http://schemas.openxmlformats.org/drawingml/2006/main" xmlns:p="http://schemas.openxmlformats.org/presentationml/2006/main">
   <p:cSld>
     <p:bg>
       <p:bgPr>
@@ -3301,7 +3301,8 @@
               </a:defRPr>
             </a:pPr>
             <a:r>
-              <a:t>ВЫПУСКНАЯ КВАЛИФИКАЦИОННАЯ РАБОТА</a:t>
+              <a:t>Выпускная квалификационная работа магистра
+Направление подготовки 01.04.02 «Прикладная математика и информатика»</a:t>
             </a:r>
           </a:p>
         </p:txBody>
@@ -3371,7 +3372,7 @@
               </a:defRPr>
             </a:pPr>
             <a:r>
-              <a:t>Студент: ___________________________</a:t>
+              <a:t>Студент: Тараканов Александр Алексеевич</a:t>
             </a:r>
           </a:p>
           <a:p>
@@ -3386,7 +3387,7 @@
               </a:defRPr>
             </a:pPr>
             <a:r>
-              <a:t>Научный руководитель: ___________________________</a:t>
+              <a:t>Научный руководитель: Смирнов Дмитрий Сергеевич, доцент</a:t>
             </a:r>
           </a:p>
         </p:txBody>

</xml_diff>

<commit_message>
Fix flowchart and slide layout
- Redrew architecture diagram (Рисунок 3.1): vertical layout,
  no crossing lines, clean arrows
- Fixed slide 1: direction 01.04.02 on separate line
</commit_message>
<xml_diff>
--- a/VKRDoc/Defense_Presentation.pptx
+++ b/VKRDoc/Defense_Presentation.pptx
@@ -3223,7 +3223,8 @@
             </a:r>
             <a:br/>
             <a:r>
-              <a:t>Кафедра кибернетики</a:t>
+              <a:t>Кафедра кибернетики
+Направление 01.04.02 «Прикладная математика и информатика»</a:t>
             </a:r>
           </a:p>
         </p:txBody>
@@ -3301,8 +3302,7 @@
               </a:defRPr>
             </a:pPr>
             <a:r>
-              <a:t>Выпускная квалификационная работа магистра
-Направление подготовки 01.04.02 «Прикладная математика и информатика»</a:t>
+              <a:t>Выпускная квалификационная работа магистра</a:t>
             </a:r>
           </a:p>
         </p:txBody>

</xml_diff>

<commit_message>
Slide 2: fix misleading claim about temporal features
</commit_message>
<xml_diff>
--- a/VKRDoc/Defense_Presentation.pptx
+++ b/VKRDoc/Defense_Presentation.pptx
@@ -6085,7 +6085,7 @@
 </file>
 
 <file path=ppt/slides/slide2.xml><?xml version="1.0" encoding="utf-8"?>
-<p:sld xmlns:a="http://schemas.openxmlformats.org/drawingml/2006/main" xmlns:p="http://schemas.openxmlformats.org/presentationml/2006/main" xmlns:r="http://schemas.openxmlformats.org/officeDocument/2006/relationships">
+<p:sld xmlns:a="http://schemas.openxmlformats.org/drawingml/2006/main" xmlns:p="http://schemas.openxmlformats.org/presentationml/2006/main">
   <p:cSld>
     <p:bg>
       <p:bgPr>
@@ -6382,7 +6382,7 @@
               </a:defRPr>
             </a:pPr>
             <a:r>
-              <a:t>Временные признаки (межкадровая динамика) — недостаточно исследованный сигнал</a:t>
+              <a:t>Параллельное извлечение временных признаков с явным temporal input — не реализовано</a:t>
             </a:r>
           </a:p>
           <a:p>

</xml_diff>

<commit_message>
Slide 9: show ablation table for 3DS T=32 with all 4 models
</commit_message>
<xml_diff>
--- a/VKRDoc/Defense_Presentation.pptx
+++ b/VKRDoc/Defense_Presentation.pptx
@@ -5325,7 +5325,7 @@
 </file>
 
 <file path=ppt/slides/slide16.xml><?xml version="1.0" encoding="utf-8"?>
-<p:sld xmlns:a="http://schemas.openxmlformats.org/drawingml/2006/main" xmlns:p="http://schemas.openxmlformats.org/presentationml/2006/main" xmlns:r="http://schemas.openxmlformats.org/officeDocument/2006/relationships">
+<p:sld xmlns:a="http://schemas.openxmlformats.org/drawingml/2006/main" xmlns:p="http://schemas.openxmlformats.org/presentationml/2006/main">
   <p:cSld>
     <p:bg>
       <p:bgPr>
@@ -5415,7 +5415,7 @@
               </a:defRPr>
             </a:pPr>
             <a:r>
-              <a:t>Масштабирование: 3 датасета + T=32</a:t>
+              <a:t>Лучшие результаты: Ablation Study на 3DS, T=32</a:t>
             </a:r>
           </a:p>
         </p:txBody>
@@ -5536,7 +5536,7 @@
                         </a:defRPr>
                       </a:pPr>
                       <a:r>
-                        <a:t>Конфигурация</a:t>
+                        <a:t>Модель (3 датасета, T=32)</a:t>
                       </a:r>
                     </a:p>
                   </a:txBody>
@@ -5582,7 +5582,7 @@
                         </a:defRPr>
                       </a:pPr>
                       <a:r>
-                        <a:t>Acc</a:t>
+                        <a:t>Accuracy</a:t>
                       </a:r>
                     </a:p>
                   </a:txBody>
@@ -5630,7 +5630,7 @@
                         </a:defRPr>
                       </a:pPr>
                       <a:r>
-                        <a:t>1DS DFDC02, T=16</a:t>
+                        <a:t>A1: Full dual-path</a:t>
                       </a:r>
                     </a:p>
                   </a:txBody>
@@ -5653,7 +5653,7 @@
                         </a:defRPr>
                       </a:pPr>
                       <a:r>
-                        <a:t>0.9777</a:t>
+                        <a:t>0.9943</a:t>
                       </a:r>
                     </a:p>
                   </a:txBody>
@@ -5676,7 +5676,7 @@
                         </a:defRPr>
                       </a:pPr>
                       <a:r>
-                        <a:t>0.9253</a:t>
+                        <a:t>96.7%</a:t>
                       </a:r>
                     </a:p>
                   </a:txBody>
@@ -5699,7 +5699,7 @@
                         </a:defRPr>
                       </a:pPr>
                       <a:r>
-                        <a:t>0.075</a:t>
+                        <a:t>0.041</a:t>
                       </a:r>
                     </a:p>
                   </a:txBody>
@@ -5724,7 +5724,7 @@
                         </a:defRPr>
                       </a:pPr>
                       <a:r>
-                        <a:t>2DS +DFD01, T=16</a:t>
+                        <a:t>A2: Spatial-only</a:t>
                       </a:r>
                     </a:p>
                   </a:txBody>
@@ -5747,7 +5747,7 @@
                         </a:defRPr>
                       </a:pPr>
                       <a:r>
-                        <a:t>0.8990</a:t>
+                        <a:t>0.9904</a:t>
                       </a:r>
                     </a:p>
                   </a:txBody>
@@ -5770,7 +5770,7 @@
                         </a:defRPr>
                       </a:pPr>
                       <a:r>
-                        <a:t>0.8770</a:t>
+                        <a:t>95.8%</a:t>
                       </a:r>
                     </a:p>
                   </a:txBody>
@@ -5793,7 +5793,7 @@
                         </a:defRPr>
                       </a:pPr>
                       <a:r>
-                        <a:t>0.194</a:t>
+                        <a:t>0.047</a:t>
                       </a:r>
                     </a:p>
                   </a:txBody>
@@ -5818,7 +5818,7 @@
                         </a:defRPr>
                       </a:pPr>
                       <a:r>
-                        <a:t>3DS +CelebDF, T=16</a:t>
+                        <a:t>A3: Temporal-only</a:t>
                       </a:r>
                     </a:p>
                   </a:txBody>
@@ -5841,7 +5841,7 @@
                         </a:defRPr>
                       </a:pPr>
                       <a:r>
-                        <a:t>0.9587</a:t>
+                        <a:t>0.9883</a:t>
                       </a:r>
                     </a:p>
                   </a:txBody>
@@ -5864,7 +5864,7 @@
                         </a:defRPr>
                       </a:pPr>
                       <a:r>
-                        <a:t>0.9436</a:t>
+                        <a:t>95.4%</a:t>
                       </a:r>
                     </a:p>
                   </a:txBody>
@@ -5887,7 +5887,7 @@
                         </a:defRPr>
                       </a:pPr>
                       <a:r>
-                        <a:t>0.121</a:t>
+                        <a:t>0.046</a:t>
                       </a:r>
                     </a:p>
                   </a:txBody>
@@ -5912,7 +5912,7 @@
                         </a:defRPr>
                       </a:pPr>
                       <a:r>
-                        <a:t>3DS +CelebDF, T=32</a:t>
+                        <a:t>A4: Sequential (BiLSTM)</a:t>
                       </a:r>
                     </a:p>
                   </a:txBody>
@@ -5935,7 +5935,7 @@
                         </a:defRPr>
                       </a:pPr>
                       <a:r>
-                        <a:t>0.9943</a:t>
+                        <a:t>0.9844</a:t>
                       </a:r>
                     </a:p>
                   </a:txBody>
@@ -5958,7 +5958,7 @@
                         </a:defRPr>
                       </a:pPr>
                       <a:r>
-                        <a:t>0.9672</a:t>
+                        <a:t>94.9%</a:t>
                       </a:r>
                     </a:p>
                   </a:txBody>
@@ -5981,7 +5981,7 @@
                         </a:defRPr>
                       </a:pPr>
                       <a:r>
-                        <a:t>0.041</a:t>
+                        <a:t>0.057</a:t>
                       </a:r>
                     </a:p>
                   </a:txBody>
@@ -6026,7 +6026,7 @@
               </a:defRPr>
             </a:pPr>
             <a:r>
-              <a:t>Ключевой вывод:</a:t>
+              <a:t>Ключевые выводы:</a:t>
             </a:r>
           </a:p>
           <a:p>
@@ -6041,7 +6041,7 @@
               </a:defRPr>
             </a:pPr>
             <a:r>
-              <a:t>Мультидатасетное обучение: AUC 0.978 → 0.899 → 0.959 → 0.994</a:t>
+              <a:t>Full dual-path (A1) лидирует по всем метрикам: AUC 0.994, EER 0.041</a:t>
             </a:r>
           </a:p>
           <a:p>
@@ -6056,7 +6056,7 @@
               </a:defRPr>
             </a:pPr>
             <a:r>
-              <a:t>T=32 снижает EER на 66% (0.121 → 0.041)</a:t>
+              <a:t>Масштабирование: 1DS→2DS→3DS + T=32 повысило AUC с 0.978 до 0.994</a:t>
             </a:r>
           </a:p>
           <a:p>
@@ -6071,7 +6071,7 @@
               </a:defRPr>
             </a:pPr>
             <a:r>
-              <a:t>Full dual-path модель лидирует при всех конфигурациях на 3 датасетах</a:t>
+              <a:t>EER снизился на 66% (0.121 → 0.041) при переходе T=16 → T=32</a:t>
             </a:r>
           </a:p>
         </p:txBody>

</xml_diff>

<commit_message>
Update VKR document and defense presentation to final version
</commit_message>
<xml_diff>
--- a/VKRDoc/Defense_Presentation.pptx
+++ b/VKRDoc/Defense_Presentation.pptx
@@ -3198,7 +3198,7 @@
         <p:spPr>
           <a:xfrm>
             <a:off x="914400" y="1097280"/>
-            <a:ext cx="10332720" cy="548640"/>
+            <a:ext cx="10332720" cy="1188720"/>
           </a:xfrm>
           <a:prstGeom prst="rect">
             <a:avLst/>
@@ -3223,8 +3223,11 @@
             </a:r>
             <a:br/>
             <a:r>
-              <a:t>Кафедра кибернетики
-Направление 01.04.02 «Прикладная математика и информатика»</a:t>
+              <a:t>Кафедра № 42 «Криптология и кибербезопасность»</a:t>
+            </a:r>
+            <a:br/>
+            <a:r>
+              <a:t>Направление 01.04.02 «Прикладная математика и информатика»</a:t>
             </a:r>
           </a:p>
         </p:txBody>
@@ -3350,8 +3353,8 @@
         </p:nvSpPr>
         <p:spPr>
           <a:xfrm>
-            <a:off x="5486400" y="4754880"/>
-            <a:ext cx="5486400" cy="1097280"/>
+            <a:off x="2286000" y="4754880"/>
+            <a:ext cx="9144000" cy="1828800"/>
           </a:xfrm>
           <a:prstGeom prst="rect">
             <a:avLst/>
@@ -3372,7 +3375,10 @@
               </a:defRPr>
             </a:pPr>
             <a:r>
-              <a:t>Студент: Тараканов Александр Алексеевич</a:t>
+              <a:rPr>
+                <a:solidFill/>
+              </a:rPr>
+              <a:t>Студент группы М24-525: Тараканов Александр Алексеевич</a:t>
             </a:r>
           </a:p>
           <a:p>
@@ -3387,7 +3393,18 @@
               </a:defRPr>
             </a:pPr>
             <a:r>
-              <a:t>Научный руководитель: Смирнов Дмитрий Сергеевич, доцент</a:t>
+              <a:rPr/>
+              <a:t>Научный руководитель: к.э.н., доцент Смирнов Дмитрий Сергеевич</a:t>
+            </a:r>
+          </a:p>
+          <a:p>
+            <a:r>
+              <a:rPr>
+                <a:solidFill>
+                  <a:srgbClr val="BBCCDD"/>
+                </a:solidFill>
+              </a:rPr>
+              <a:t>Консультант: ведущий разработчик Копылов Иван Станиславович</a:t>
             </a:r>
           </a:p>
         </p:txBody>
@@ -3400,7 +3417,7 @@
         </p:nvSpPr>
         <p:spPr>
           <a:xfrm>
-            <a:off x="914400" y="6126480"/>
+            <a:off x="914400" y="6492240"/>
             <a:ext cx="10332720" cy="457200"/>
           </a:xfrm>
           <a:prstGeom prst="rect">
@@ -3916,7 +3933,7 @@
               </a:defRPr>
             </a:pPr>
             <a:r>
-              <a:t>Confusion Matrix и ROC (in-domain, DFDC02)</a:t>
+              <a:t>Confusion Matrix и ROC (A1 Full, 3DS T=32)</a:t>
             </a:r>
           </a:p>
         </p:txBody>
@@ -4132,7 +4149,7 @@
               </a:defRPr>
             </a:pPr>
             <a:r>
-              <a:t>Ablation study и анализ</a:t>
+              <a:t>Анализ результатов: per-domain и cross-dataset</a:t>
             </a:r>
           </a:p>
         </p:txBody>
@@ -4236,133 +4253,34 @@
             <a:spAutoFit/>
           </a:bodyPr>
           <a:lstStyle/>
-          <a:p/>
-          <a:p>
-            <a:pPr>
-              <a:spcBef>
-                <a:spcPts val="600"/>
-              </a:spcBef>
-              <a:defRPr sz="1800" b="1">
-                <a:solidFill>
-                  <a:srgbClr val="003366"/>
-                </a:solidFill>
-              </a:defRPr>
-            </a:pPr>
-            <a:r>
-              <a:t>Ранжирование по AUC:</a:t>
-            </a:r>
-          </a:p>
-          <a:p>
-            <a:pPr>
-              <a:spcBef>
-                <a:spcPts val="600"/>
-              </a:spcBef>
-              <a:defRPr sz="1600" b="0">
-                <a:solidFill>
-                  <a:srgbClr val="000000"/>
-                </a:solidFill>
-              </a:defRPr>
-            </a:pPr>
-            <a:r>
-              <a:t>Spatial-only (0.9835)</a:t>
-            </a:r>
-          </a:p>
-          <a:p>
-            <a:pPr>
-              <a:spcBef>
-                <a:spcPts val="600"/>
-              </a:spcBef>
-              <a:defRPr sz="1600" b="0">
-                <a:solidFill>
-                  <a:srgbClr val="000000"/>
-                </a:solidFill>
-              </a:defRPr>
-            </a:pPr>
-            <a:r>
-              <a:t>Dual-path full (0.9777)</a:t>
-            </a:r>
-          </a:p>
-          <a:p>
-            <a:pPr>
-              <a:spcBef>
-                <a:spcPts val="600"/>
-              </a:spcBef>
-              <a:defRPr sz="1600" b="0">
-                <a:solidFill>
-                  <a:srgbClr val="000000"/>
-                </a:solidFill>
-              </a:defRPr>
-            </a:pPr>
-            <a:r>
-              <a:t>Sequential CNN+BiLSTM (0.9715)</a:t>
-            </a:r>
-          </a:p>
-          <a:p>
-            <a:pPr>
-              <a:spcBef>
-                <a:spcPts val="600"/>
-              </a:spcBef>
-              <a:defRPr sz="1600" b="0">
-                <a:solidFill>
-                  <a:srgbClr val="000000"/>
-                </a:solidFill>
-              </a:defRPr>
-            </a:pPr>
-            <a:r>
-              <a:t>Temporal-only (0.9655)</a:t>
-            </a:r>
-          </a:p>
-          <a:p>
-            <a:pPr>
-              <a:spcBef>
-                <a:spcPts val="2000"/>
-              </a:spcBef>
-              <a:defRPr sz="1800" b="1">
-                <a:solidFill>
-                  <a:srgbClr val="003366"/>
-                </a:solidFill>
-              </a:defRPr>
-            </a:pPr>
-            <a:r>
-              <a:t>Ключевые выводы:</a:t>
-            </a:r>
-          </a:p>
-          <a:p>
-            <a:pPr>
-              <a:spcBef>
-                <a:spcPts val="600"/>
-              </a:spcBef>
-              <a:defRPr sz="1500" b="0">
-                <a:solidFill>
-                  <a:srgbClr val="000000"/>
-                </a:solidFill>
-              </a:defRPr>
-            </a:pPr>
-            <a:r>
-              <a:t>Temporal-only (0.9655) подтверждает:</a:t>
-            </a:r>
-            <a:br/>
-            <a:r>
-              <a:t>frame differences — самостоятельный дискриминативный сигнал</a:t>
-            </a:r>
-          </a:p>
-          <a:p>
-            <a:pPr>
-              <a:spcBef>
-                <a:spcPts val="1000"/>
-              </a:spcBef>
-              <a:defRPr sz="1500" b="0">
-                <a:solidFill>
-                  <a:srgbClr val="000000"/>
-                </a:solidFill>
-              </a:defRPr>
-            </a:pPr>
-            <a:r>
-              <a:t>Sequential (0.9715) &lt; Spatial (0.9835):</a:t>
-            </a:r>
-            <a:br/>
-            <a:r>
-              <a:t>каскадная обработка ухудшает результат</a:t>
+          <a:p>
+            <a:r>
+              <a:t>Per-domain AUC на тестовой выборке 3DS T=16:</a:t>
+            </a:r>
+          </a:p>
+          <a:p>
+            <a:r>
+              <a:t>DFDC02:    AUC = 0.984</a:t>
+            </a:r>
+          </a:p>
+          <a:p>
+            <a:r>
+              <a:t>Celeb-DF v2: AUC = 0.997</a:t>
+            </a:r>
+          </a:p>
+          <a:p>
+            <a:r>
+              <a:t>DFD01:     AUC = 0.574  (n_real=54)</a:t>
+            </a:r>
+          </a:p>
+          <a:p>
+            <a:r>
+              <a:t/>
+            </a:r>
+          </a:p>
+          <a:p>
+            <a:r>
+              <a:t>Малое число real в DFD01 - оценка нестабильна</a:t>
             </a:r>
           </a:p>
         </p:txBody>
@@ -4442,67 +4360,32 @@
               </a:defRPr>
             </a:pPr>
             <a:r>
-              <a:t>Валидация гипотез</a:t>
-            </a:r>
-          </a:p>
-          <a:p>
-            <a:pPr>
-              <a:spcBef>
-                <a:spcPts val="1200"/>
-              </a:spcBef>
-              <a:defRPr sz="1500" b="0">
-                <a:solidFill>
-                  <a:srgbClr val="000000"/>
-                </a:solidFill>
-              </a:defRPr>
-            </a:pPr>
-            <a:r>
-              <a:t>✓  Временные признаки несут независимую информацию</a:t>
-            </a:r>
-          </a:p>
-          <a:p>
-            <a:pPr>
-              <a:spcBef>
-                <a:spcPts val="800"/>
-              </a:spcBef>
-              <a:defRPr sz="1500" b="0">
-                <a:solidFill>
-                  <a:srgbClr val="000000"/>
-                </a:solidFill>
-              </a:defRPr>
-            </a:pPr>
-            <a:r>
-              <a:t>✓  Параллельная обработка лучше последовательной</a:t>
-            </a:r>
-          </a:p>
-          <a:p>
-            <a:pPr>
-              <a:spcBef>
-                <a:spcPts val="800"/>
-              </a:spcBef>
-              <a:defRPr sz="1500" b="0">
-                <a:solidFill>
-                  <a:srgbClr val="000000"/>
-                </a:solidFill>
-              </a:defRPr>
-            </a:pPr>
-            <a:r>
-              <a:t>✓  Frame differences — эффективная репрезентация</a:t>
-            </a:r>
-          </a:p>
-          <a:p>
-            <a:pPr>
-              <a:spcBef>
-                <a:spcPts val="1200"/>
-              </a:spcBef>
-              <a:defRPr sz="1500" b="1">
-                <a:solidFill>
-                  <a:srgbClr val="CC5500"/>
-                </a:solidFill>
-              </a:defRPr>
-            </a:pPr>
-            <a:r>
-              <a:t>→  Cross-dataset (DFDC02→DFD01): dual-path показал преимущество</a:t>
+              <a:t>Cross-dataset DFDC02 -&gt; DFD01:</a:t>
+            </a:r>
+          </a:p>
+          <a:p>
+            <a:r>
+              <a:t>A1 Full (dual-path):  AUC = 0.553</a:t>
+            </a:r>
+          </a:p>
+          <a:p>
+            <a:r>
+              <a:t>A2 Spatial-only:       AUC = 0.504</a:t>
+            </a:r>
+          </a:p>
+          <a:p>
+            <a:r>
+              <a:t>Δ = +0.049 в пользу dual-path</a:t>
+            </a:r>
+          </a:p>
+          <a:p>
+            <a:r>
+              <a:t/>
+            </a:r>
+          </a:p>
+          <a:p>
+            <a:r>
+              <a:t>Согласуется с DeepfakeBench [25]: 15-25 % падение</a:t>
             </a:r>
           </a:p>
         </p:txBody>
@@ -4561,7 +4444,7 @@
         <p:spPr>
           <a:xfrm>
             <a:off x="6492240" y="4389120"/>
-            <a:ext cx="4937760" cy="1280160"/>
+            <a:ext cx="4937760" cy="2011680"/>
           </a:xfrm>
           <a:prstGeom prst="rect">
             <a:avLst/>
@@ -4582,37 +4465,22 @@
               </a:defRPr>
             </a:pPr>
             <a:r>
-              <a:t>Практическая применимость</a:t>
-            </a:r>
-          </a:p>
-          <a:p>
-            <a:pPr>
-              <a:spcBef>
-                <a:spcPts val="800"/>
-              </a:spcBef>
-              <a:defRPr sz="1500" b="0">
-                <a:solidFill>
-                  <a:srgbClr val="000000"/>
-                </a:solidFill>
-              </a:defRPr>
-            </a:pPr>
-            <a:r>
-              <a:t>Flask MVP: веб-интерфейс для анализа видео</a:t>
-            </a:r>
-          </a:p>
-          <a:p>
-            <a:pPr>
-              <a:spcBef>
-                <a:spcPts val="600"/>
-              </a:spcBef>
-              <a:defRPr sz="1500" b="0">
-                <a:solidFill>
-                  <a:srgbClr val="666666"/>
-                </a:solidFill>
-              </a:defRPr>
-            </a:pPr>
-            <a:r>
-              <a:t>Загрузка видео → детектирование → результат</a:t>
+              <a:t>Fusion веса (12 demo видео):</a:t>
+            </a:r>
+          </a:p>
+          <a:p>
+            <a:r>
+              <a:t>α_spatial для fakes:  0.928</a:t>
+            </a:r>
+          </a:p>
+          <a:p>
+            <a:r>
+              <a:t>α_spatial для real:   0.646</a:t>
+            </a:r>
+          </a:p>
+          <a:p>
+            <a:r>
+              <a:t>α_temporal для real:  0.354</a:t>
             </a:r>
           </a:p>
         </p:txBody>
@@ -4874,52 +4742,17 @@
               </a:defRPr>
             </a:pPr>
             <a:r>
-              <a:t>Научная новизна</a:t>
-            </a:r>
-          </a:p>
-          <a:p>
-            <a:pPr>
-              <a:spcBef>
-                <a:spcPts val="1600"/>
-              </a:spcBef>
-              <a:defRPr sz="1500" b="0">
-                <a:solidFill>
-                  <a:srgbClr val="000000"/>
-                </a:solidFill>
-              </a:defRPr>
-            </a:pPr>
-            <a:r>
-              <a:t>1.  Параллельная dual-path архитектура с независимыми spatial и temporal ветвями</a:t>
-            </a:r>
-          </a:p>
-          <a:p>
-            <a:pPr>
-              <a:spcBef>
-                <a:spcPts val="1600"/>
-              </a:spcBef>
-              <a:defRPr sz="1500" b="0">
-                <a:solidFill>
-                  <a:srgbClr val="000000"/>
-                </a:solidFill>
-              </a:defRPr>
-            </a:pPr>
-            <a:r>
-              <a:t>2.  Frame differences как явный temporal input (вместо optical flow или raw RGB)</a:t>
-            </a:r>
-          </a:p>
-          <a:p>
-            <a:pPr>
-              <a:spcBef>
-                <a:spcPts val="1600"/>
-              </a:spcBef>
-              <a:defRPr sz="1500" b="0">
-                <a:solidFill>
-                  <a:srgbClr val="000000"/>
-                </a:solidFill>
-              </a:defRPr>
-            </a:pPr>
-            <a:r>
-              <a:t>3.  Систематическая классификация пространственных и временных артефактов deepfake</a:t>
+              <a:t>1. Параллельная dual-path архитектура с явным временным входом (frame differences) - конкретная конфигурация EffNet-B4 + EffNet-B0 + Transformer + adaptive fusion</a:t>
+            </a:r>
+          </a:p>
+          <a:p>
+            <a:r>
+              <a:t>2. Систематическая ablation: 4 архитектуры x 2 значения T x 1/2/3 датасета в идентичных условиях</a:t>
+            </a:r>
+          </a:p>
+          <a:p>
+            <a:r>
+              <a:t>3. Воспроизводимый pipeline на PyTorch + Flask MVP, открытый код</a:t>
             </a:r>
           </a:p>
         </p:txBody>
@@ -5336,83 +5169,27 @@
               </a:defRPr>
             </a:pPr>
             <a:r>
-              <a:t>Текущие ограничения</a:t>
-            </a:r>
-          </a:p>
-          <a:p>
-            <a:pPr>
-              <a:spcBef>
-                <a:spcPts val="1400"/>
-              </a:spcBef>
-              <a:defRPr sz="1500" b="0">
-                <a:solidFill>
-                  <a:srgbClr val="000000"/>
-                </a:solidFill>
-              </a:defRPr>
-            </a:pPr>
-            <a:r>
-              <a:t>Обучение выполнено на трёх датасетах (10023 видео)</a:t>
-            </a:r>
-            <a:br/>
-            <a:r>
-              <a:t>Cross-dataset и multi-dataset evaluation выполнены</a:t>
-            </a:r>
-          </a:p>
-          <a:p>
-            <a:pPr>
-              <a:spcBef>
-                <a:spcPts val="1400"/>
-              </a:spcBef>
-              <a:defRPr sz="1500" b="0">
-                <a:solidFill>
-                  <a:srgbClr val="000000"/>
-                </a:solidFill>
-              </a:defRPr>
-            </a:pPr>
-            <a:r>
-              <a:t>Исследованы T=16 и T=32</a:t>
-            </a:r>
-            <a:br/>
-            <a:r>
-              <a:t>(не адаптируется к длине видео)</a:t>
-            </a:r>
-          </a:p>
-          <a:p>
-            <a:pPr>
-              <a:spcBef>
-                <a:spcPts val="1400"/>
-              </a:spcBef>
-              <a:defRPr sz="1500" b="0">
-                <a:solidFill>
-                  <a:srgbClr val="000000"/>
-                </a:solidFill>
-              </a:defRPr>
-            </a:pPr>
-            <a:r>
-              <a:t>Бинарная классификация</a:t>
-            </a:r>
-            <a:br/>
-            <a:r>
-              <a:t>(без определения типа манипуляции)</a:t>
-            </a:r>
-          </a:p>
-          <a:p>
-            <a:pPr>
-              <a:spcBef>
-                <a:spcPts val="1400"/>
-              </a:spcBef>
-              <a:defRPr sz="1500" b="0">
-                <a:solidFill>
-                  <a:srgbClr val="000000"/>
-                </a:solidFill>
-              </a:defRPr>
-            </a:pPr>
-            <a:r>
-              <a:t>3 датасета, 3 метода генерации</a:t>
-            </a:r>
-            <a:br/>
-            <a:r>
-              <a:t>(DFDC02+DFD01+CelebDF)</a:t>
+              <a:t>Per-domain разница: DFD01 AUC = 0.574 (n_real=54, оценка нестабильна)</a:t>
+            </a:r>
+          </a:p>
+          <a:p>
+            <a:r>
+              <a:t>Cross-dataset перенос: 43 % падение AUC (0.978 → 0.553)</a:t>
+            </a:r>
+          </a:p>
+          <a:p>
+            <a:r>
+              <a:t>Бинарная классификация (без типа манипуляции)</a:t>
+            </a:r>
+          </a:p>
+          <a:p>
+            <a:r>
+              <a:t>Только 3 датасета, 3 метода генерации</a:t>
+            </a:r>
+          </a:p>
+          <a:p>
+            <a:r>
+              <a:t>Адаптивный выбор T не реализован</a:t>
             </a:r>
           </a:p>
         </p:txBody>
@@ -5752,80 +5529,74 @@
             <a:spAutoFit/>
           </a:bodyPr>
           <a:lstStyle/>
-          <a:p/>
-          <a:p>
-            <a:pPr>
-              <a:spcBef>
-                <a:spcPts val="1400"/>
-              </a:spcBef>
-              <a:defRPr sz="1700" b="0">
+          <a:p>
+            <a:r>
+              <a:rPr>
                 <a:solidFill>
                   <a:srgbClr val="FFFFFF"/>
                 </a:solidFill>
-              </a:defRPr>
-            </a:pPr>
-            <a:r>
-              <a:t>Разработан метод детектирования deepfake с dual-path архитектурой, объединяющей параллельные пространственную и временную ветви</a:t>
-            </a:r>
-          </a:p>
-          <a:p>
-            <a:pPr>
-              <a:spcBef>
-                <a:spcPts val="1400"/>
-              </a:spcBef>
-              <a:defRPr sz="1700" b="0">
+              </a:rPr>
+              <a:t>Основные результаты:</a:t>
+            </a:r>
+          </a:p>
+          <a:p>
+            <a:r>
+              <a:rPr>
                 <a:solidFill>
                   <a:srgbClr val="FFFFFF"/>
                 </a:solidFill>
-              </a:defRPr>
-            </a:pPr>
-            <a:r>
-              <a:t>Достигнут AUC 0.994 на трёх датасетах при T=32 (DFDC02+DFD01+CelebDF, ~10000 видео)</a:t>
-            </a:r>
-          </a:p>
-          <a:p>
-            <a:pPr>
-              <a:spcBef>
-                <a:spcPts val="1400"/>
-              </a:spcBef>
-              <a:defRPr sz="1700" b="0">
+              </a:rPr>
+              <a:t>1. Реализована dual-path архитектура: EffNet-B4 + EffNet-B0 + Transformer + adaptive fusion</a:t>
+            </a:r>
+          </a:p>
+          <a:p>
+            <a:r>
+              <a:rPr>
                 <a:solidFill>
                   <a:srgbClr val="FFFFFF"/>
                 </a:solidFill>
-              </a:defRPr>
-            </a:pPr>
-            <a:r>
-              <a:t>Ablation study подтвердил вклад каждого компонента и валидность архитектурных решений</a:t>
-            </a:r>
-          </a:p>
-          <a:p>
-            <a:pPr>
-              <a:spcBef>
-                <a:spcPts val="1400"/>
-              </a:spcBef>
-              <a:defRPr sz="1700" b="0">
+              </a:rPr>
+              <a:t>2. На 3 датасетах при T=32 достигнуты AUC = 0.994, Acc = 96.7 %, F1 = 0.978, EER = 0.041</a:t>
+            </a:r>
+          </a:p>
+          <a:p>
+            <a:r>
+              <a:rPr>
                 <a:solidFill>
                   <a:srgbClr val="FFFFFF"/>
                 </a:solidFill>
-              </a:defRPr>
-            </a:pPr>
-            <a:r>
-              <a:t>T=32 повысило AUC с 0.959 (T=16) до 0.994 (T=32), EER снизился на 66%</a:t>
-            </a:r>
-          </a:p>
-          <a:p>
-            <a:pPr>
-              <a:spcBef>
-                <a:spcPts val="1400"/>
-              </a:spcBef>
-              <a:defRPr sz="1700" b="0">
+              </a:rPr>
+              <a:t>3. Полный воспроизводимый pipeline на PyTorch + Flask MVP</a:t>
+            </a:r>
+          </a:p>
+          <a:p>
+            <a:r>
+              <a:rPr>
                 <a:solidFill>
                   <a:srgbClr val="FFFFFF"/>
                 </a:solidFill>
-              </a:defRPr>
-            </a:pPr>
-            <a:r>
-              <a:t>Реализован полный воспроизводимый pipeline + Flask MVP для практического применения</a:t>
+              </a:rPr>
+              <a:t/>
+            </a:r>
+          </a:p>
+          <a:p>
+            <a:r>
+              <a:rPr>
+                <a:solidFill>
+                  <a:srgbClr val="FFFFFF"/>
+                </a:solidFill>
+              </a:rPr>
+              <a:t>Ablation подтвердил вклад каждого компонента архитектуры</a:t>
+            </a:r>
+          </a:p>
+          <a:p>
+            <a:r>
+              <a:rPr>
+                <a:solidFill>
+                  <a:srgbClr val="FFFFFF"/>
+                </a:solidFill>
+              </a:rPr>
+              <a:t>Cross-dataset проверка показала ожидаемую деградацию AUC ~ 43 %</a:t>
             </a:r>
           </a:p>
         </p:txBody>
@@ -5895,6 +5666,7 @@
               </a:defRPr>
             </a:pPr>
             <a:r>
+              <a:rPr/>
               <a:t>Готов ответить на ваши вопросы</a:t>
             </a:r>
           </a:p>
@@ -6116,7 +5888,7 @@
               </a:defRPr>
             </a:pPr>
             <a:r>
-              <a:t>Deepfake — реалистичные синтетические видео (face swap, reenactment, lip-sync)</a:t>
+              <a:t>Deepfake - реалистичные синтетические видео (face swap, reenactment, lip-sync)</a:t>
             </a:r>
           </a:p>
           <a:p>
@@ -6206,7 +5978,7 @@
               </a:defRPr>
             </a:pPr>
             <a:r>
-              <a:t>Параллельное извлечение временных признаков с явным temporal input — не реализовано</a:t>
+              <a:t>Параллельное извлечение пространственных и временных признаков с явным временным входом в литературе встречается реже, чем последовательные и 3D-свёрточные подходы</a:t>
             </a:r>
           </a:p>
           <a:p>
@@ -6221,7 +5993,7 @@
               </a:defRPr>
             </a:pPr>
             <a:r>
-              <a:t>Большинство методов рассматривают кадры независимо или используют последовательный pipeline</a:t>
+              <a:t>Большинство методов рассматривают кадры независимо или используют последовательный pipeline (CNN+LSTM)</a:t>
             </a:r>
           </a:p>
         </p:txBody>
@@ -6457,7 +6229,7 @@
               </a:defRPr>
             </a:pPr>
             <a:r>
-              <a:t>Разработка метода детектирования манипулированных видео на основе параллельного пространственно-временного анализа</a:t>
+              <a:t>Разработка метода детектирования манипулированных видео на основе параллельного пространственно-временного анализа и его экспериментальная оценка</a:t>
             </a:r>
           </a:p>
           <a:p>
@@ -6547,7 +6319,7 @@
               </a:defRPr>
             </a:pPr>
             <a:r>
-              <a:t>5.  Экспериментальная оценка (ablation study по компонентам)</a:t>
+              <a:t>5.  Экспериментальная оценка: ablation study, T=16 vs T=32, multi-dataset, cross-dataset</a:t>
             </a:r>
           </a:p>
         </p:txBody>
@@ -9004,7 +8776,7 @@
               </a:defRPr>
             </a:pPr>
             <a:r>
-              <a:t>Backbone Scale</a:t>
+              <a:t>Размер основной сети</a:t>
             </a:r>
           </a:p>
         </p:txBody>
@@ -9082,7 +8854,7 @@
             </a:r>
             <a:br/>
             <a:r>
-              <a:t>Более лёгкий backbone для temporal</a:t>
+              <a:t>Более лёгкая сеть для временной ветви</a:t>
             </a:r>
           </a:p>
         </p:txBody>
@@ -9683,7 +9455,7 @@
               </a:defRPr>
             </a:pPr>
             <a:r>
-              <a:t>Разделение по video-ID (без утечки данных)</a:t>
+              <a:t>Разделение по video-ID - одно видео не попадает и в train, и в val</a:t>
             </a:r>
           </a:p>
           <a:p>
@@ -9698,7 +9470,7 @@
               </a:defRPr>
             </a:pPr>
             <a:r>
-              <a:t>Clip-consistent augmentation</a:t>
+              <a:t>Clip-consistent augmentation - одна и та же аугментация на всех кадрах клипа</a:t>
             </a:r>
           </a:p>
           <a:p>
@@ -9728,7 +9500,7 @@
               </a:defRPr>
             </a:pPr>
             <a:r>
-              <a:t>AdamW optimizer</a:t>
+              <a:t>AdamW - стандартный оптимизатор для дообучения предобученных сетей</a:t>
             </a:r>
           </a:p>
           <a:p>
@@ -9743,7 +9515,7 @@
               </a:defRPr>
             </a:pPr>
             <a:r>
-              <a:t>Differential LR: backbone 1e-4, head 3e-4</a:t>
+              <a:t>Разные скорости обучения: основная сеть 1e-4 (бережём ImageNet-веса), классификатор 3e-4</a:t>
             </a:r>
           </a:p>
           <a:p>
@@ -9758,7 +9530,7 @@
               </a:defRPr>
             </a:pPr>
             <a:r>
-              <a:t>CosineAnnealing LR scheduler</a:t>
+              <a:t>CosineAnnealing LR scheduler - плавное снижение скорости обучения</a:t>
             </a:r>
           </a:p>
         </p:txBody>
@@ -9812,7 +9584,7 @@
               </a:defRPr>
             </a:pPr>
             <a:r>
-              <a:t>Warmup: 5 эпох (замороженный backbone)</a:t>
+              <a:t>Warmup (прогрев): первые 5 эпох основная сеть заморожена, учим только классификатор</a:t>
             </a:r>
           </a:p>
           <a:p>
@@ -9827,7 +9599,7 @@
               </a:defRPr>
             </a:pPr>
             <a:r>
-              <a:t>Unfreeze: 2 последних блока</a:t>
+              <a:t>Разморозка: дообучаем 2 последних блока основной сети</a:t>
             </a:r>
           </a:p>
           <a:p>
@@ -9842,7 +9614,7 @@
               </a:defRPr>
             </a:pPr>
             <a:r>
-              <a:t>Early stopping (patience=7)</a:t>
+              <a:t>Early stopping - автоостановка (patience=7: 7 эпох без прироста → стоп)</a:t>
             </a:r>
           </a:p>
           <a:p>
@@ -9857,7 +9629,7 @@
               </a:defRPr>
             </a:pPr>
             <a:r>
-              <a:t>AUC как primary metric</a:t>
+              <a:t>AUC - главная метрика, по ней выбирается лучшая версия модели</a:t>
             </a:r>
           </a:p>
           <a:p>
@@ -9887,7 +9659,7 @@
               </a:defRPr>
             </a:pPr>
             <a:r>
-              <a:t>Kaggle P100 GPU</a:t>
+              <a:t>Kaggle P100 GPU - бесплатный облачный GPU для обучения</a:t>
             </a:r>
           </a:p>
           <a:p>
@@ -9902,7 +9674,7 @@
               </a:defRPr>
             </a:pPr>
             <a:r>
-              <a:t>30 эпох максимум</a:t>
+              <a:t>30 эпох максимум - верхний предел, реально остановились на эп. 28+7</a:t>
             </a:r>
           </a:p>
           <a:p>
@@ -9917,7 +9689,7 @@
               </a:defRPr>
             </a:pPr>
             <a:r>
-              <a:t>Mixed precision (AMP)</a:t>
+              <a:t>Mixed precision (AMP) - умножения в fp16, градиенты в fp32. Без этого batch=8 не влезал бы в 16 GB памяти GPU</a:t>
             </a:r>
           </a:p>
         </p:txBody>
@@ -10021,7 +9793,7 @@
               </a:defRPr>
             </a:pPr>
             <a:r>
-              <a:t>Результаты: In-domain evaluation</a:t>
+              <a:t>[этап 1] Результаты: In-domain evaluation (DFDC02, T=16)</a:t>
             </a:r>
           </a:p>
         </p:txBody>
@@ -10236,7 +10008,7 @@
                         </a:defRPr>
                       </a:pPr>
                       <a:r>
-                        <a:t>Spatial-only (B1)</a:t>
+                        <a:t>Spatial-only (A2)</a:t>
                       </a:r>
                     </a:p>
                   </a:txBody>
@@ -10330,7 +10102,7 @@
                         </a:defRPr>
                       </a:pPr>
                       <a:r>
-                        <a:t>Sequential CNN+BiLSTM (B3)</a:t>
+                        <a:t>Sequential CNN+BiLSTM (A4)</a:t>
                       </a:r>
                     </a:p>
                   </a:txBody>
@@ -10647,7 +10419,7 @@
               </a:defRPr>
             </a:pPr>
             <a:r>
-              <a:t>Spatial-only лидирует в in-domain (AUC 0.9835) за счёт dataset-specific артефактов</a:t>
+              <a:t>Spatial-only лидирует in-domain (AUC 0.9835) за счёт пространственных артефактов конкретного датасета</a:t>
             </a:r>
           </a:p>
           <a:p>
@@ -10662,7 +10434,7 @@
               </a:defRPr>
             </a:pPr>
             <a:r>
-              <a:t>Dual-path (0.9777) успешно объединяет оба типа сигналов без потери качества</a:t>
+              <a:t/>
             </a:r>
           </a:p>
           <a:p>
@@ -10677,7 +10449,7 @@
               </a:defRPr>
             </a:pPr>
             <a:r>
-              <a:t>Cross-dataset evaluation (DFDC02 → DFD01) подтвердила преимущество dual-path при обобщении</a:t>
+              <a:t>Dual-path (0.9777) объединяет оба типа сигналов; на cross-dataset переносе DFDC02 -&gt; DFD01 dual-path 0.553 показал на 5 п.п. AUC лучше spatial 0.504</a:t>
             </a:r>
           </a:p>
         </p:txBody>
@@ -10781,7 +10553,7 @@
               </a:defRPr>
             </a:pPr>
             <a:r>
-              <a:t>Лучшие результаты: Ablation Study на 3DS, T=32</a:t>
+              <a:t>[ГЛАВНЫЙ РЕЗУЛЬТАТ] Ablation Study на 3DS, T=32</a:t>
             </a:r>
           </a:p>
         </p:txBody>
@@ -11407,7 +11179,7 @@
               </a:defRPr>
             </a:pPr>
             <a:r>
-              <a:t>Full dual-path (A1) лидирует по всем метрикам: AUC 0.994, EER 0.041</a:t>
+              <a:t>Full dual-path (A1): AUC = 0.994, Accuracy = 96.7 %, F1 = 0.978, EER = 0.041 - наилучшая конфигурация</a:t>
             </a:r>
           </a:p>
           <a:p>
@@ -11437,7 +11209,7 @@
               </a:defRPr>
             </a:pPr>
             <a:r>
-              <a:t>EER снизился на 66% (0.121 → 0.041) при переходе T=16 → T=32</a:t>
+              <a:t>EER снизился на 66 % (0.121 → 0.041) при переходе T=16 → T=32</a:t>
             </a:r>
           </a:p>
         </p:txBody>

</xml_diff>